<commit_message>
Update product planning documentation
</commit_message>
<xml_diff>
--- a/docs/AI内容工业化平台建设方案-老板汇报版.pptx
+++ b/docs/AI内容工业化平台建设方案-老板汇报版.pptx
@@ -7034,7 +7034,7 @@
                 <a:latin typeface="Microsoft YaHei"/>
                 <a:ea typeface="Microsoft YaHei"/>
               </a:rPr>
-              <a:t>复杂权限、完整多人协同、大规模资产市场</a:t>
+              <a:t>复杂岗位权限、传统多人协同、大规模资产市场</a:t>
             </a:r>
             <a:endParaRPr lang="zh-CN" sz="900"/>
           </a:p>
@@ -7370,7 +7370,7 @@
                 <a:latin typeface="Microsoft YaHei"/>
                 <a:ea typeface="Microsoft YaHei"/>
               </a:rPr>
-              <a:t>流程、模型效果、成本、协作方式和资产沉淀</a:t>
+              <a:t>流程、模型效果、成本、单人主导效率和资产沉淀</a:t>
             </a:r>
             <a:endParaRPr lang="zh-CN" sz="900"/>
           </a:p>
@@ -10673,7 +10673,7 @@
                 <a:latin typeface="Microsoft YaHei"/>
                 <a:ea typeface="Microsoft YaHei"/>
               </a:rPr>
-              <a:t>Next.js / React</a:t>
+              <a:t>Next.js / React / TypeScript</a:t>
             </a:r>
             <a:endParaRPr lang="zh-CN" sz="900"/>
           </a:p>
@@ -10889,7 +10889,7 @@
                 <a:latin typeface="Microsoft YaHei"/>
                 <a:ea typeface="Microsoft YaHei"/>
               </a:rPr>
-              <a:t>FastAPI / Node.js</a:t>
+              <a:t>FastAPI</a:t>
             </a:r>
             <a:endParaRPr lang="zh-CN" sz="800"/>
           </a:p>
@@ -11321,7 +11321,7 @@
                 <a:latin typeface="Microsoft YaHei"/>
                 <a:ea typeface="Microsoft YaHei"/>
               </a:rPr>
-              <a:t>MinIO / OSS / COS</a:t>
+              <a:t>MinIO / S3</a:t>
             </a:r>
             <a:endParaRPr lang="zh-CN" sz="800"/>
           </a:p>
@@ -11537,7 +11537,7 @@
                 <a:latin typeface="Microsoft YaHei"/>
                 <a:ea typeface="Microsoft YaHei"/>
               </a:rPr>
-              <a:t>Redis + Celery / BullMQ</a:t>
+              <a:t>Redis + Celery</a:t>
             </a:r>
             <a:endParaRPr lang="zh-CN" sz="800"/>
           </a:p>
@@ -21401,7 +21401,7 @@
                 <a:latin typeface="Microsoft YaHei"/>
                 <a:ea typeface="Microsoft YaHei"/>
               </a:rPr>
-              <a:t>行业背景：从纯人工经验驱动，走向人工创意 + AI 辅助生产 + 平台化管理</a:t>
+              <a:t>行业背景：从纯人工经验驱动，走向创作者主导 + AI 驱动生产 + 平台化管理</a:t>
             </a:r>
             <a:endParaRPr lang="zh-CN" sz="1100"/>
           </a:p>

</xml_diff>